<commit_message>
Updated ResearchGPT project files
</commit_message>
<xml_diff>
--- a/project_presentation.pptx
+++ b/project_presentation.pptx
@@ -259,7 +259,7 @@
       <p15:sldGuideLst xmlns:p15="http://schemas.microsoft.com/office/powerpoint/2012/main"/>
     </p:ext>
     <p:ext uri="GoogleSlidesCustomDataVersion2">
-      <go:slidesCustomData xmlns="" xmlns:go="http://customooxmlschemas.google.com/" xmlns:ahyp="http://schemas.microsoft.com/office/drawing/2018/hyperlinkcolor" xmlns:p15="http://schemas.microsoft.com/office/powerpoint/2012/main" xmlns:p14="http://schemas.microsoft.com/office/powerpoint/2010/main" xmlns:com="http://schemas.openxmlformats.org/drawingml/2006/compatibility" xmlns:pvml="urn:schemas-microsoft-com:office:powerpoint" xmlns:v="urn:schemas-microsoft-com:vml" xmlns:o="urn:schemas-microsoft-com:office:office" xmlns:dgm="http://schemas.openxmlformats.org/drawingml/2006/diagram" xmlns:c="http://schemas.openxmlformats.org/drawingml/2006/chart" xmlns:mv="urn:schemas-microsoft-com:mac:vml" xmlns:mc="http://schemas.openxmlformats.org/markup-compatibility/2006" r:id="rId27" roundtripDataSignature="AMtx7mjt3491jQ7aCoyIz2WXeHKroE7tpQ=="/>
+      <go:slidesCustomData xmlns:mc="http://schemas.openxmlformats.org/markup-compatibility/2006" xmlns:mv="urn:schemas-microsoft-com:mac:vml" xmlns:c="http://schemas.openxmlformats.org/drawingml/2006/chart" xmlns:dgm="http://schemas.openxmlformats.org/drawingml/2006/diagram" xmlns:o="urn:schemas-microsoft-com:office:office" xmlns:v="urn:schemas-microsoft-com:vml" xmlns:pvml="urn:schemas-microsoft-com:office:powerpoint" xmlns:com="http://schemas.openxmlformats.org/drawingml/2006/compatibility" xmlns:p14="http://schemas.microsoft.com/office/powerpoint/2010/main" xmlns:p15="http://schemas.microsoft.com/office/powerpoint/2012/main" xmlns:ahyp="http://schemas.microsoft.com/office/drawing/2018/hyperlinkcolor" xmlns:go="http://customooxmlschemas.google.com/" xmlns="" r:id="rId27" roundtripDataSignature="AMtx7mjt3491jQ7aCoyIz2WXeHKroE7tpQ=="/>
     </p:ext>
   </p:extLst>
 </p:presentation>
@@ -12605,20 +12605,7 @@
                 <a:cs typeface="Times New Roman"/>
                 <a:sym typeface="Times New Roman"/>
               </a:rPr>
-              <a:t>– </a:t>
-            </a:r>
-            <a:r>
-              <a:rPr lang="en-US" sz="1850" dirty="0">
-                <a:solidFill>
-                  <a:srgbClr val="2B3541"/>
-                </a:solidFill>
-                <a:latin typeface="Times New Roman"/>
-                <a:ea typeface="Times New Roman"/>
-                <a:cs typeface="Times New Roman"/>
-                <a:sym typeface="Times New Roman"/>
-                <a:hlinkClick r:id="rId3"/>
-              </a:rPr>
-              <a:t>https://github.com/theunstopabble/Researchex-AI</a:t>
+              <a:t>– https://github.com/surajrajput999/ResearchGPT.git</a:t>
             </a:r>
             <a:endParaRPr sz="1850" b="0" i="0" u="none" strike="noStrike" cap="none" dirty="0">
               <a:solidFill>
@@ -13067,7 +13054,7 @@
           <p:nvPr>
             <p:extLst>
               <p:ext uri="{D42A27DB-BD31-4B8C-83A1-F6EECF244321}">
-                <p14:modId xmlns:p14="http://schemas.microsoft.com/office/powerpoint/2010/main" val="3331969411"/>
+                <p14:modId xmlns:p14="http://schemas.microsoft.com/office/powerpoint/2010/main" val="3626736382"/>
               </p:ext>
             </p:extLst>
           </p:nvPr>
@@ -13498,7 +13485,7 @@
                       </a:pPr>
                       <a:r>
                         <a:rPr lang="en-IN" dirty="0"/>
-                        <a:t>Gautam Kumar</a:t>
+                        <a:t>Suraj Bhan Pratap Singh</a:t>
                       </a:r>
                       <a:endParaRPr dirty="0"/>
                     </a:p>
@@ -13644,7 +13631,7 @@
                       </a:pPr>
                       <a:r>
                         <a:rPr lang="en-IN" sz="1200" dirty="0"/>
-                        <a:t>gautamkumar43421@gmail.com</a:t>
+                        <a:t>surajdona2005@gmail.com</a:t>
                       </a:r>
                       <a:endParaRPr sz="1200" dirty="0"/>
                     </a:p>
@@ -13731,7 +13718,7 @@
                       </a:pPr>
                       <a:r>
                         <a:rPr lang="en-IN" dirty="0"/>
-                        <a:t>+91 6207793196</a:t>
+                        <a:t>+91 7209690361</a:t>
                       </a:r>
                       <a:endParaRPr dirty="0"/>
                     </a:p>
@@ -13865,19 +13852,19 @@
           <a:lstStyle/>
           <a:p>
             <a:r>
-              <a:rPr lang="en-US" sz="2400" b="1" dirty="0"/>
+              <a:rPr lang="en-US" sz="2400" b="1"/>
               <a:t>Project Title – </a:t>
             </a:r>
             <a:r>
-              <a:rPr lang="en-IN" sz="2400" dirty="0">
+              <a:rPr lang="en-IN" sz="2400">
                 <a:highlight>
                   <a:srgbClr val="FFFF00"/>
                 </a:highlight>
               </a:rPr>
-              <a:t>Researchex-AI</a:t>
+              <a:t>ResearchGPT</a:t>
             </a:r>
             <a:r>
-              <a:rPr lang="en-US" sz="2400" dirty="0">
+              <a:rPr lang="en-US" sz="2400">
                 <a:highlight>
                   <a:srgbClr val="FFFF00"/>
                 </a:highlight>
@@ -13913,8 +13900,8 @@
         </p:blipFill>
         <p:spPr>
           <a:xfrm>
-            <a:off x="4055201" y="3721122"/>
-            <a:ext cx="898215" cy="903478"/>
+            <a:off x="4098727" y="3721122"/>
+            <a:ext cx="811162" cy="903478"/>
           </a:xfrm>
           <a:prstGeom prst="rect">
             <a:avLst/>

</xml_diff>